<commit_message>
M3T1 Lessons 1-3: decks, videos, bell work + exit tickets (test style), IEP/504 versions, book slides with answers
- make_m3t1_lessons.py builds, for each lesson and class day: slide deck (.html/.pptx), narrated video,
  online + printed bell work and printed exit ticket (with keys) written like the End of Topic 1 test,
  and IEP / Section 504 versions of the decks, online bell work and printed sheets
- make_m3t1_keys.py: publisher LessonSlides with red click-to-reveal answers (inline under each part,
  floating only beside number lines, tables and pictures), SE page labels, Essential stars, Skip/Optional badges;
  corrections slides (TE Q10 answers in Lesson 2, slide typos in Lessons 1-3)
- make_lesson_key.annotate gains skips=(); make_m3t1_plans.py pulls bell work / exit tickets from the lessons
- teacher.html: Module 3 Topic 1 section (all versions); archive.html rebuilt; make_m3t1_lesson1.py folded in

Co-Authored-By: Claude Opus 5.5 <noreply@anthropic.com>
</commit_message>
<xml_diff>
--- a/Module 3 topic 1/m3t1-lesson1-solving-linear-equations.pptx
+++ b/Module 3 topic 1/m3t1-lesson1-solving-linear-equations.pptx
@@ -291,7 +291,7 @@
           <a:p>
             <a:r>
               <a:rPr lang="en-US" dirty="0"/>
-              <a:t>Question 4 and the TE's Seeing Structure questions. Stamp the learning: a linear equation has one solution, no solution, or infinite solutions. Question 3 is the TE's check point; Skills Practice Set B.</a:t>
+              <a:t>Question 4 and the TE's Seeing Structure questions. Stamp the learning: one solution, no solution, or infinite solutions. Skills Practice Set B.</a:t>
             </a:r>
           </a:p>
         </p:txBody>
@@ -409,7 +409,7 @@
           <a:p>
             <a:r>
               <a:rPr lang="en-US" dirty="0"/>
-              <a:t>Not starred; included because End of Topic question 11 is the same kind of problem (triangle area = rectangle area). Skip if short on time.</a:t>
+              <a:t>Not starred; included because End of Topic question 11 is the same kind of problem. Skip if short on time.</a:t>
             </a:r>
           </a:p>
         </p:txBody>
@@ -527,7 +527,7 @@
           <a:p>
             <a:r>
               <a:rPr lang="en-US" dirty="0"/>
-              <a:t>Added for this deck; not from the textbook. Give 3–4 minutes, collect the answers, and use them to decide who needs Skills Practice. Work: 1. 1 − 3p = 5 − 2p → −p = 4 → p = −4. 2. 2x − 3 = −1.5x + 4 → 3.5x = 7 → x = 2. 3. 4x + 3 = 4x + 4: same x-coefficient, different constants, so 3 = 4 is never true. 4. ½(6)(x + 5) = 4(x − 1) → 3x + 15 = 4x − 4 → x = 19. Like test Q2, Q4, Q5 and Q11.</a:t>
+              <a:t>Printed copy: EXIT TICKET/T1-Exit-Ticket-Thu-11-05.pdf (written like the End of Topic 1 test). Give about 8 minutes. Work: 1. 1 − 3p = 5 − 2p → −p = 4 → p = −4. 2. 2x − 3 = −1.5x + 4 → 3.5x = 7 → x = 2. 3. 4x + 3 = 4x + 4: same x-coefficient, different constants, so 3 = 4 is never true. 4. ½(6)(x + 5) = 4(x − 1) → 3x + 15 = 4x − 4 → x = 19.</a:t>
             </a:r>
           </a:p>
         </p:txBody>
@@ -1557,6 +1557,16 @@
               </a:lnSpc>
             </a:pPr>
             <a:r>
+              <a:rPr lang="en-US" sz="1800" dirty="0">
+                <a:solidFill>
+                  <a:srgbClr val="16171D"/>
+                </a:solidFill>
+                <a:latin typeface="Segoe UI"/>
+                <a:cs typeface="Segoe UI"/>
+              </a:rPr>
+              <a:t xml:space="preserve">Bell work: </a:t>
+            </a:r>
+            <a:r>
               <a:rPr lang="en-US" sz="1800" dirty="0" b="1">
                 <a:solidFill>
                   <a:srgbClr val="3050B8"/>
@@ -1565,7 +1575,7 @@
                 <a:cs typeface="Segoe UI"/>
                 <a:hlinkClick r:id="rId3"/>
               </a:rPr>
-              <a:t xml:space="preserve">Bell work →</a:t>
+              <a:t xml:space="preserve">Day 1 →</a:t>
             </a:r>
             <a:endParaRPr lang="en-US" sz="1800" dirty="0"/>
           </a:p>
@@ -7924,7 +7934,7 @@
                 <a:latin typeface="Segoe UI"/>
                 <a:cs typeface="Segoe UI"/>
               </a:rPr>
-              <a:t xml:space="preserve">Exit Ticket</a:t>
+              <a:t xml:space="preserve">Day 1 · Exit Ticket</a:t>
             </a:r>
             <a:endParaRPr lang="en-US" sz="1200" dirty="0"/>
           </a:p>
@@ -7982,7 +7992,7 @@
         </p:nvSpPr>
         <p:spPr>
           <a:xfrm>
-            <a:off x="685800" y="1675638"/>
+            <a:off x="685800" y="1656588"/>
             <a:ext cx="10820095" cy="352044"/>
           </a:xfrm>
           <a:prstGeom prst="rect">
@@ -8076,7 +8086,7 @@
         </p:nvSpPr>
         <p:spPr>
           <a:xfrm>
-            <a:off x="685800" y="2141982"/>
+            <a:off x="685800" y="2103882"/>
             <a:ext cx="2244715" cy="518922"/>
           </a:xfrm>
           <a:prstGeom prst="roundRect">
@@ -8134,7 +8144,7 @@
         </p:nvSpPr>
         <p:spPr>
           <a:xfrm>
-            <a:off x="685800" y="2775204"/>
+            <a:off x="685800" y="2718054"/>
             <a:ext cx="10820095" cy="352044"/>
           </a:xfrm>
           <a:prstGeom prst="rect">
@@ -8228,7 +8238,7 @@
         </p:nvSpPr>
         <p:spPr>
           <a:xfrm>
-            <a:off x="685800" y="3241548"/>
+            <a:off x="685800" y="3165348"/>
             <a:ext cx="2742194" cy="518922"/>
           </a:xfrm>
           <a:prstGeom prst="roundRect">
@@ -8296,7 +8306,7 @@
         </p:nvSpPr>
         <p:spPr>
           <a:xfrm>
-            <a:off x="685800" y="3874770"/>
+            <a:off x="685800" y="3779520"/>
             <a:ext cx="10820095" cy="352044"/>
           </a:xfrm>
           <a:prstGeom prst="rect">
@@ -8390,7 +8400,7 @@
         </p:nvSpPr>
         <p:spPr>
           <a:xfrm>
-            <a:off x="685800" y="4341114"/>
+            <a:off x="685800" y="4226814"/>
             <a:ext cx="3737153" cy="518922"/>
           </a:xfrm>
           <a:prstGeom prst="roundRect">
@@ -8448,7 +8458,7 @@
         </p:nvSpPr>
         <p:spPr>
           <a:xfrm>
-            <a:off x="685800" y="4974336"/>
+            <a:off x="685800" y="4840986"/>
             <a:ext cx="10820095" cy="352044"/>
           </a:xfrm>
           <a:prstGeom prst="rect">
@@ -8592,7 +8602,7 @@
         </p:nvSpPr>
         <p:spPr>
           <a:xfrm>
-            <a:off x="685800" y="5440680"/>
+            <a:off x="685800" y="5288280"/>
             <a:ext cx="2908021" cy="518922"/>
           </a:xfrm>
           <a:prstGeom prst="roundRect">
@@ -9230,14 +9240,14 @@
       </p:sp>
       <p:sp>
         <p:nvSpPr>
-          <p:cNvPr id="7" name="Shape 7"/>
+          <p:cNvPr id="6" name="Shape 6"/>
           <p:cNvSpPr txBox="1"/>
           <p:nvPr/>
         </p:nvSpPr>
         <p:spPr>
           <a:xfrm>
             <a:off x="685800" y="1618488"/>
-            <a:ext cx="5219548" cy="1738122"/>
+            <a:ext cx="10820095" cy="1107948"/>
           </a:xfrm>
           <a:prstGeom prst="roundRect">
             <a:avLst>
@@ -9277,7 +9287,7 @@
         <p:spPr>
           <a:xfrm>
             <a:off x="895350" y="1789938"/>
-            <a:ext cx="4800448" cy="374904"/>
+            <a:ext cx="10400995" cy="374904"/>
           </a:xfrm>
           <a:prstGeom prst="rect">
             <a:avLst/>
@@ -9321,7 +9331,7 @@
         <p:spPr>
           <a:xfrm>
             <a:off x="895350" y="2260092"/>
-            <a:ext cx="4800448" cy="534924"/>
+            <a:ext cx="10400995" cy="294894"/>
           </a:xfrm>
           <a:prstGeom prst="rect">
             <a:avLst/>
@@ -9350,7 +9360,7 @@
                 <a:latin typeface="Segoe UI"/>
                 <a:cs typeface="Segoe UI"/>
               </a:rPr>
-              <a:t xml:space="preserve">1a–e: solve and write the property for each step.</a:t>
+              <a:t xml:space="preserve">1a–e: solve and write the property for each step. 2a–f: one solution, no solution, or infinite?</a:t>
             </a:r>
             <a:endParaRPr lang="en-US" sz="1575" dirty="0"/>
           </a:p>
@@ -9358,180 +9368,7 @@
       </p:sp>
       <p:sp>
         <p:nvSpPr>
-          <p:cNvPr id="6" name="Shape 6"/>
-          <p:cNvSpPr txBox="1"/>
-          <p:nvPr/>
-        </p:nvSpPr>
-        <p:spPr>
-          <a:xfrm>
-            <a:off x="895350" y="2890266"/>
-            <a:ext cx="4800448" cy="294894"/>
-          </a:xfrm>
-          <a:prstGeom prst="rect">
-            <a:avLst/>
-          </a:prstGeom>
-          <a:noFill/>
-          <a:ln>
-            <a:noFill/>
-          </a:ln>
-        </p:spPr>
-        <p:txBody>
-          <a:bodyPr wrap="square" lIns="36576" tIns="27432" rIns="36576" bIns="27432" anchor="t">
-            <a:noAutofit/>
-          </a:bodyPr>
-          <a:lstStyle/>
-          <a:p>
-            <a:pPr algn="l">
-              <a:lnSpc>
-                <a:spcPct val="100000"/>
-              </a:lnSpc>
-            </a:pPr>
-            <a:r>
-              <a:rPr lang="en-US" sz="1575" dirty="0">
-                <a:solidFill>
-                  <a:srgbClr val="16171D"/>
-                </a:solidFill>
-                <a:latin typeface="Segoe UI"/>
-                <a:cs typeface="Segoe UI"/>
-              </a:rPr>
-              <a:t xml:space="preserve">2a–f: one solution, no solution, or infinite?</a:t>
-            </a:r>
-            <a:endParaRPr lang="en-US" sz="1575" dirty="0"/>
-          </a:p>
-        </p:txBody>
-      </p:sp>
-      <p:sp>
-        <p:nvSpPr>
-          <p:cNvPr id="10" name="Shape 10"/>
-          <p:cNvSpPr txBox="1"/>
-          <p:nvPr/>
-        </p:nvSpPr>
-        <p:spPr>
-          <a:xfrm>
-            <a:off x="6286348" y="1618488"/>
-            <a:ext cx="5219548" cy="1347978"/>
-          </a:xfrm>
-          <a:prstGeom prst="roundRect">
-            <a:avLst>
-              <a:gd name="adj" fmla="val 8000"/>
-            </a:avLst>
-          </a:prstGeom>
-          <a:solidFill>
-            <a:srgbClr val="FFFFFF"/>
-          </a:solidFill>
-          <a:ln w="12700">
-            <a:solidFill>
-              <a:srgbClr val="E3E4EC"/>
-            </a:solidFill>
-          </a:ln>
-        </p:spPr>
-        <p:txBody>
-          <a:bodyPr wrap="square" lIns="36576" tIns="27432" rIns="36576" bIns="27432" anchor="t">
-            <a:noAutofit/>
-          </a:bodyPr>
-          <a:lstStyle/>
-          <a:p>
-            <a:pPr algn="l">
-              <a:lnSpc>
-                <a:spcPct val="100000"/>
-              </a:lnSpc>
-            </a:pPr>
-            <a:endParaRPr lang="en-US" sz="1950" dirty="0"/>
-          </a:p>
-        </p:txBody>
-      </p:sp>
-      <p:sp>
-        <p:nvSpPr>
-          <p:cNvPr id="8" name="Shape 8"/>
-          <p:cNvSpPr txBox="1"/>
-          <p:nvPr/>
-        </p:nvSpPr>
-        <p:spPr>
-          <a:xfrm>
-            <a:off x="6495898" y="1789938"/>
-            <a:ext cx="4800448" cy="374904"/>
-          </a:xfrm>
-          <a:prstGeom prst="rect">
-            <a:avLst/>
-          </a:prstGeom>
-          <a:noFill/>
-          <a:ln>
-            <a:noFill/>
-          </a:ln>
-        </p:spPr>
-        <p:txBody>
-          <a:bodyPr wrap="square" lIns="36576" tIns="27432" rIns="36576" bIns="27432" anchor="t">
-            <a:noAutofit/>
-          </a:bodyPr>
-          <a:lstStyle/>
-          <a:p>
-            <a:pPr algn="l">
-              <a:lnSpc>
-                <a:spcPct val="100000"/>
-              </a:lnSpc>
-            </a:pPr>
-            <a:r>
-              <a:rPr lang="en-US" sz="2100" dirty="0" b="1">
-                <a:solidFill>
-                  <a:srgbClr val="3050B8"/>
-                </a:solidFill>
-                <a:latin typeface="Segoe UI"/>
-                <a:cs typeface="Segoe UI"/>
-                <a:hlinkClick r:id="rId3"/>
-              </a:rPr>
-              <a:t xml:space="preserve">Bell work →</a:t>
-            </a:r>
-            <a:endParaRPr lang="en-US" sz="2100" dirty="0"/>
-          </a:p>
-        </p:txBody>
-      </p:sp>
-      <p:sp>
-        <p:nvSpPr>
-          <p:cNvPr id="9" name="Shape 9"/>
-          <p:cNvSpPr txBox="1"/>
-          <p:nvPr/>
-        </p:nvSpPr>
-        <p:spPr>
-          <a:xfrm>
-            <a:off x="6495898" y="2260092"/>
-            <a:ext cx="4800448" cy="534924"/>
-          </a:xfrm>
-          <a:prstGeom prst="rect">
-            <a:avLst/>
-          </a:prstGeom>
-          <a:noFill/>
-          <a:ln>
-            <a:noFill/>
-          </a:ln>
-        </p:spPr>
-        <p:txBody>
-          <a:bodyPr wrap="square" lIns="36576" tIns="27432" rIns="36576" bIns="27432" anchor="t">
-            <a:noAutofit/>
-          </a:bodyPr>
-          <a:lstStyle/>
-          <a:p>
-            <a:pPr algn="l">
-              <a:lnSpc>
-                <a:spcPct val="100000"/>
-              </a:lnSpc>
-            </a:pPr>
-            <a:r>
-              <a:rPr lang="en-US" sz="1575" dirty="0">
-                <a:solidFill>
-                  <a:srgbClr val="16171D"/>
-                </a:solidFill>
-                <a:latin typeface="Segoe UI"/>
-                <a:cs typeface="Segoe UI"/>
-              </a:rPr>
-              <a:t xml:space="preserve">Today's 4 warm-up questions online, scored on submit.</a:t>
-            </a:r>
-            <a:endParaRPr lang="en-US" sz="1575" dirty="0"/>
-          </a:p>
-        </p:txBody>
-      </p:sp>
-      <p:sp>
-        <p:nvSpPr>
-          <p:cNvPr id="11" name="Slide Number 11"/>
+          <p:cNvPr id="7" name="Slide Number 7"/>
           <p:cNvSpPr txBox="1"/>
           <p:nvPr/>
         </p:nvSpPr>

</xml_diff>